<commit_message>
Update docs to include real screenshots and mermaid diagrams
</commit_message>
<xml_diff>
--- a/docs-scripts/Presentasi_HRIS.pptx
+++ b/docs-scripts/Presentasi_HRIS.pptx
@@ -3394,6 +3394,30 @@
           </a:p>
         </p:txBody>
       </p:sp>
+      <p:pic>
+        <p:nvPicPr>
+          <p:cNvPr id="4" name="Picture 3" descr="auth_flow.png"/>
+          <p:cNvPicPr>
+            <a:picLocks noChangeAspect="1"/>
+          </p:cNvPicPr>
+          <p:nvPr/>
+        </p:nvPicPr>
+        <p:blipFill>
+          <a:blip r:embed="rId2"/>
+          <a:stretch>
+            <a:fillRect/>
+          </a:stretch>
+        </p:blipFill>
+        <p:spPr>
+          <a:xfrm>
+            <a:off x="5029200" y="1371600"/>
+            <a:ext cx="3657600" cy="5019230"/>
+          </a:xfrm>
+          <a:prstGeom prst="rect">
+            <a:avLst/>
+          </a:prstGeom>
+        </p:spPr>
+      </p:pic>
     </p:spTree>
   </p:cSld>
   <p:clrMapOvr>

</xml_diff>

<commit_message>
Add ERD, Use Case, extra page screenshots to documentation
</commit_message>
<xml_diff>
--- a/docs-scripts/Presentasi_HRIS.pptx
+++ b/docs-scripts/Presentasi_HRIS.pptx
@@ -12,6 +12,9 @@
     <p:sldId id="260" r:id="rId11"/>
     <p:sldId id="261" r:id="rId12"/>
     <p:sldId id="262" r:id="rId13"/>
+    <p:sldId id="263" r:id="rId14"/>
+    <p:sldId id="264" r:id="rId15"/>
+    <p:sldId id="265" r:id="rId16"/>
   </p:sldIdLst>
   <p:sldSz cx="9144000" cy="6858000" type="screen4x3"/>
   <p:notesSz cx="6858000" cy="9144000"/>
@@ -3156,6 +3159,80 @@
 </p:sld>
 </file>
 
+<file path=ppt/slides/slide10.xml><?xml version="1.0" encoding="utf-8"?>
+<p:sld xmlns:a="http://schemas.openxmlformats.org/drawingml/2006/main" xmlns:p="http://schemas.openxmlformats.org/presentationml/2006/main" xmlns:r="http://schemas.openxmlformats.org/officeDocument/2006/relationships">
+  <p:cSld>
+    <p:spTree>
+      <p:nvGrpSpPr>
+        <p:cNvPr id="1" name=""/>
+        <p:cNvGrpSpPr/>
+        <p:nvPr/>
+      </p:nvGrpSpPr>
+      <p:grpSpPr/>
+      <p:sp>
+        <p:nvSpPr>
+          <p:cNvPr id="2" name="Title 1"/>
+          <p:cNvSpPr>
+            <a:spLocks noGrp="1"/>
+          </p:cNvSpPr>
+          <p:nvPr>
+            <p:ph type="title"/>
+          </p:nvPr>
+        </p:nvSpPr>
+        <p:spPr/>
+        <p:txBody>
+          <a:bodyPr/>
+          <a:lstStyle/>
+          <a:p>
+            <a:r>
+              <a:t>Kesimpulan &amp; ROI</a:t>
+            </a:r>
+          </a:p>
+        </p:txBody>
+      </p:sp>
+      <p:sp>
+        <p:nvSpPr>
+          <p:cNvPr id="3" name="Content Placeholder 2"/>
+          <p:cNvSpPr>
+            <a:spLocks noGrp="1"/>
+          </p:cNvSpPr>
+          <p:nvPr>
+            <p:ph idx="1"/>
+          </p:nvPr>
+        </p:nvSpPr>
+        <p:spPr/>
+        <p:txBody>
+          <a:bodyPr/>
+          <a:lstStyle/>
+          <a:p/>
+          <a:p>
+            <a:pPr/>
+            <a:r>
+              <a:t>Sistem telah memodernisasi cara perusahaan melacak absensi.</a:t>
+            </a:r>
+          </a:p>
+          <a:p>
+            <a:pPr/>
+            <a:r>
+              <a:t>Meningkatkan kedisiplinan dan mencegah fraud dengan teknologi cerdas.</a:t>
+            </a:r>
+          </a:p>
+          <a:p>
+            <a:pPr/>
+            <a:r>
+              <a:t>Menghemat waktu ratusan jam per bulan untuk perekapan gaji.</a:t>
+            </a:r>
+          </a:p>
+        </p:txBody>
+      </p:sp>
+    </p:spTree>
+  </p:cSld>
+  <p:clrMapOvr>
+    <a:masterClrMapping/>
+  </p:clrMapOvr>
+</p:sld>
+</file>
+
 <file path=ppt/slides/slide2.xml><?xml version="1.0" encoding="utf-8"?>
 <p:sld xmlns:a="http://schemas.openxmlformats.org/drawingml/2006/main" xmlns:p="http://schemas.openxmlformats.org/presentationml/2006/main" xmlns:r="http://schemas.openxmlformats.org/officeDocument/2006/relationships">
   <p:cSld>
@@ -3502,6 +3579,30 @@
           </a:p>
         </p:txBody>
       </p:sp>
+      <p:pic>
+        <p:nvPicPr>
+          <p:cNvPr id="4" name="Picture 3" descr="3_attendance.png"/>
+          <p:cNvPicPr>
+            <a:picLocks noChangeAspect="1"/>
+          </p:cNvPicPr>
+          <p:nvPr/>
+        </p:nvPicPr>
+        <p:blipFill>
+          <a:blip r:embed="rId2"/>
+          <a:stretch>
+            <a:fillRect/>
+          </a:stretch>
+        </p:blipFill>
+        <p:spPr>
+          <a:xfrm>
+            <a:off x="4572000" y="1371600"/>
+            <a:ext cx="4114800" cy="2314575"/>
+          </a:xfrm>
+          <a:prstGeom prst="rect">
+            <a:avLst/>
+          </a:prstGeom>
+        </p:spPr>
+      </p:pic>
     </p:spTree>
   </p:cSld>
   <p:clrMapOvr>
@@ -3614,7 +3715,7 @@
           <a:lstStyle/>
           <a:p>
             <a:r>
-              <a:t>Kesimpulan &amp; Dampak Positif</a:t>
+              <a:t>Perancangan Sistem: ERD</a:t>
             </a:r>
           </a:p>
         </p:txBody>
@@ -3633,31 +3734,217 @@
         <p:txBody>
           <a:bodyPr/>
           <a:lstStyle/>
-          <a:p>
-            <a:r>
-              <a:t>Return on Investment (ROI):</a:t>
-            </a:r>
-          </a:p>
-          <a:p>
-            <a:pPr lvl="1"/>
-            <a:r>
-              <a:t>Memangkas waktu administratif hingga 80%.</a:t>
-            </a:r>
-          </a:p>
-          <a:p>
-            <a:pPr lvl="1"/>
-            <a:r>
-              <a:t>Disiplin Karyawan Meningkat Drastis.</a:t>
-            </a:r>
-          </a:p>
-          <a:p>
-            <a:pPr lvl="1"/>
-            <a:r>
-              <a:t>Pengambilan keputusan berbasis data yang akurat.</a:t>
-            </a:r>
-          </a:p>
-        </p:txBody>
-      </p:sp>
+          <a:p/>
+        </p:txBody>
+      </p:sp>
+      <p:pic>
+        <p:nvPicPr>
+          <p:cNvPr id="4" name="Picture 3" descr="erd.png"/>
+          <p:cNvPicPr>
+            <a:picLocks noChangeAspect="1"/>
+          </p:cNvPicPr>
+          <p:nvPr/>
+        </p:nvPicPr>
+        <p:blipFill>
+          <a:blip r:embed="rId2"/>
+          <a:stretch>
+            <a:fillRect/>
+          </a:stretch>
+        </p:blipFill>
+        <p:spPr>
+          <a:xfrm>
+            <a:off x="1371600" y="1371600"/>
+            <a:ext cx="6400800" cy="8036114"/>
+          </a:xfrm>
+          <a:prstGeom prst="rect">
+            <a:avLst/>
+          </a:prstGeom>
+        </p:spPr>
+      </p:pic>
+    </p:spTree>
+  </p:cSld>
+  <p:clrMapOvr>
+    <a:masterClrMapping/>
+  </p:clrMapOvr>
+</p:sld>
+</file>
+
+<file path=ppt/slides/slide8.xml><?xml version="1.0" encoding="utf-8"?>
+<p:sld xmlns:a="http://schemas.openxmlformats.org/drawingml/2006/main" xmlns:p="http://schemas.openxmlformats.org/presentationml/2006/main" xmlns:r="http://schemas.openxmlformats.org/officeDocument/2006/relationships">
+  <p:cSld>
+    <p:spTree>
+      <p:nvGrpSpPr>
+        <p:cNvPr id="1" name=""/>
+        <p:cNvGrpSpPr/>
+        <p:nvPr/>
+      </p:nvGrpSpPr>
+      <p:grpSpPr/>
+      <p:sp>
+        <p:nvSpPr>
+          <p:cNvPr id="2" name="Title 1"/>
+          <p:cNvSpPr>
+            <a:spLocks noGrp="1"/>
+          </p:cNvSpPr>
+          <p:nvPr>
+            <p:ph type="title"/>
+          </p:nvPr>
+        </p:nvSpPr>
+        <p:spPr/>
+        <p:txBody>
+          <a:bodyPr/>
+          <a:lstStyle/>
+          <a:p>
+            <a:r>
+              <a:t>Perancangan Sistem: Use Case Diagram</a:t>
+            </a:r>
+          </a:p>
+        </p:txBody>
+      </p:sp>
+      <p:sp>
+        <p:nvSpPr>
+          <p:cNvPr id="3" name="Content Placeholder 2"/>
+          <p:cNvSpPr>
+            <a:spLocks noGrp="1"/>
+          </p:cNvSpPr>
+          <p:nvPr>
+            <p:ph idx="1"/>
+          </p:nvPr>
+        </p:nvSpPr>
+        <p:spPr/>
+        <p:txBody>
+          <a:bodyPr/>
+          <a:lstStyle/>
+          <a:p/>
+        </p:txBody>
+      </p:sp>
+      <p:pic>
+        <p:nvPicPr>
+          <p:cNvPr id="4" name="Picture 3" descr="use_case.png"/>
+          <p:cNvPicPr>
+            <a:picLocks noChangeAspect="1"/>
+          </p:cNvPicPr>
+          <p:nvPr/>
+        </p:nvPicPr>
+        <p:blipFill>
+          <a:blip r:embed="rId2"/>
+          <a:stretch>
+            <a:fillRect/>
+          </a:stretch>
+        </p:blipFill>
+        <p:spPr>
+          <a:xfrm>
+            <a:off x="1828800" y="1371600"/>
+            <a:ext cx="5486400" cy="7101042"/>
+          </a:xfrm>
+          <a:prstGeom prst="rect">
+            <a:avLst/>
+          </a:prstGeom>
+        </p:spPr>
+      </p:pic>
+    </p:spTree>
+  </p:cSld>
+  <p:clrMapOvr>
+    <a:masterClrMapping/>
+  </p:clrMapOvr>
+</p:sld>
+</file>
+
+<file path=ppt/slides/slide9.xml><?xml version="1.0" encoding="utf-8"?>
+<p:sld xmlns:a="http://schemas.openxmlformats.org/drawingml/2006/main" xmlns:p="http://schemas.openxmlformats.org/presentationml/2006/main" xmlns:r="http://schemas.openxmlformats.org/officeDocument/2006/relationships">
+  <p:cSld>
+    <p:spTree>
+      <p:nvGrpSpPr>
+        <p:cNvPr id="1" name=""/>
+        <p:cNvGrpSpPr/>
+        <p:nvPr/>
+      </p:nvGrpSpPr>
+      <p:grpSpPr/>
+      <p:sp>
+        <p:nvSpPr>
+          <p:cNvPr id="2" name="Title 1"/>
+          <p:cNvSpPr>
+            <a:spLocks noGrp="1"/>
+          </p:cNvSpPr>
+          <p:nvPr>
+            <p:ph type="title"/>
+          </p:nvPr>
+        </p:nvSpPr>
+        <p:spPr/>
+        <p:txBody>
+          <a:bodyPr/>
+          <a:lstStyle/>
+          <a:p>
+            <a:r>
+              <a:t>Modul Cuti, Laporan, &amp; Manajemen Karyawan</a:t>
+            </a:r>
+          </a:p>
+        </p:txBody>
+      </p:sp>
+      <p:sp>
+        <p:nvSpPr>
+          <p:cNvPr id="3" name="Content Placeholder 2"/>
+          <p:cNvSpPr>
+            <a:spLocks noGrp="1"/>
+          </p:cNvSpPr>
+          <p:nvPr>
+            <p:ph idx="1"/>
+          </p:nvPr>
+        </p:nvSpPr>
+        <p:spPr/>
+        <p:txBody>
+          <a:bodyPr/>
+          <a:lstStyle/>
+          <a:p/>
+        </p:txBody>
+      </p:sp>
+      <p:pic>
+        <p:nvPicPr>
+          <p:cNvPr id="4" name="Picture 3" descr="3_attendance.png"/>
+          <p:cNvPicPr>
+            <a:picLocks noChangeAspect="1"/>
+          </p:cNvPicPr>
+          <p:nvPr/>
+        </p:nvPicPr>
+        <p:blipFill>
+          <a:blip r:embed="rId2"/>
+          <a:stretch>
+            <a:fillRect/>
+          </a:stretch>
+        </p:blipFill>
+        <p:spPr>
+          <a:xfrm>
+            <a:off x="914400" y="1371600"/>
+            <a:ext cx="3200400" cy="1800225"/>
+          </a:xfrm>
+          <a:prstGeom prst="rect">
+            <a:avLst/>
+          </a:prstGeom>
+        </p:spPr>
+      </p:pic>
+      <p:pic>
+        <p:nvPicPr>
+          <p:cNvPr id="5" name="Picture 4" descr="6_reports.png"/>
+          <p:cNvPicPr>
+            <a:picLocks noChangeAspect="1"/>
+          </p:cNvPicPr>
+          <p:nvPr/>
+        </p:nvPicPr>
+        <p:blipFill>
+          <a:blip r:embed="rId3"/>
+          <a:stretch>
+            <a:fillRect/>
+          </a:stretch>
+        </p:blipFill>
+        <p:spPr>
+          <a:xfrm>
+            <a:off x="4572000" y="1371600"/>
+            <a:ext cx="3200400" cy="1800225"/>
+          </a:xfrm>
+          <a:prstGeom prst="rect">
+            <a:avLst/>
+          </a:prstGeom>
+        </p:spPr>
+      </p:pic>
     </p:spTree>
   </p:cSld>
   <p:clrMapOvr>

</xml_diff>

<commit_message>
Fix screenshot capturing to show correct roles and mobile/desktop views
</commit_message>
<xml_diff>
--- a/docs-scripts/Presentasi_HRIS.pptx
+++ b/docs-scripts/Presentasi_HRIS.pptx
@@ -3596,7 +3596,7 @@
         <p:spPr>
           <a:xfrm>
             <a:off x="4572000" y="1371600"/>
-            <a:ext cx="4114800" cy="2314575"/>
+            <a:ext cx="4114800" cy="7005711"/>
           </a:xfrm>
           <a:prstGeom prst="rect">
             <a:avLst/>
@@ -3899,7 +3899,7 @@
       </p:sp>
       <p:pic>
         <p:nvPicPr>
-          <p:cNvPr id="4" name="Picture 3" descr="3_attendance.png"/>
+          <p:cNvPr id="4" name="Picture 3" descr="5_employees.png"/>
           <p:cNvPicPr>
             <a:picLocks noChangeAspect="1"/>
           </p:cNvPicPr>

</xml_diff>

<commit_message>
Capture full page screenshots for dashboard and other scrollable pages
</commit_message>
<xml_diff>
--- a/docs-scripts/Presentasi_HRIS.pptx
+++ b/docs-scripts/Presentasi_HRIS.pptx
@@ -3914,7 +3914,7 @@
         <p:spPr>
           <a:xfrm>
             <a:off x="914400" y="1371600"/>
-            <a:ext cx="3200400" cy="1800225"/>
+            <a:ext cx="3200400" cy="2700338"/>
           </a:xfrm>
           <a:prstGeom prst="rect">
             <a:avLst/>
@@ -3938,7 +3938,7 @@
         <p:spPr>
           <a:xfrm>
             <a:off x="4572000" y="1371600"/>
-            <a:ext cx="3200400" cy="1800225"/>
+            <a:ext cx="3200400" cy="2700338"/>
           </a:xfrm>
           <a:prstGeom prst="rect">
             <a:avLst/>

</xml_diff>

<commit_message>
Regenerate docs with 1920x1080 desktop resolution and fullPage mode
</commit_message>
<xml_diff>
--- a/docs-scripts/Presentasi_HRIS.pptx
+++ b/docs-scripts/Presentasi_HRIS.pptx
@@ -3914,7 +3914,7 @@
         <p:spPr>
           <a:xfrm>
             <a:off x="914400" y="1371600"/>
-            <a:ext cx="3200400" cy="2700338"/>
+            <a:ext cx="3200400" cy="1800225"/>
           </a:xfrm>
           <a:prstGeom prst="rect">
             <a:avLst/>
@@ -3938,7 +3938,7 @@
         <p:spPr>
           <a:xfrm>
             <a:off x="4572000" y="1371600"/>
-            <a:ext cx="3200400" cy="2700338"/>
+            <a:ext cx="3200400" cy="1800225"/>
           </a:xfrm>
           <a:prstGeom prst="rect">
             <a:avLst/>

</xml_diff>